<commit_message>
fix(paper): show the lowest-cost candidate of six families in Figure 4(e) and move the Ni-Co plane to Figure S5(c)
Figure 4(e) now marks, month by month, which candidate is cheapest in the six
families where the lowest-cost candidate changes over the 92 monthly price
states, so the panel shows that the ammonia-cracking crossover is not a single
case. The nickel-cobalt price plane moves to SI Figure S5(c), where an enlarged
view placed clear of the monthly states names September and October 2025.
Figure S5 becomes one row of three panels, the SI lists the months of every
candidate, and Figure S6 precedes its paragraph so that no SI page is left
mostly empty. The main text cites Figure 4e for the six families and Figure
S5c for the price plane; numbers are unchanged (4,997 of 5,000 word equivalents).

Audit entry H54.

Co-Authored-By: Claude Fable 5.1 <noreply@anthropic.com>
</commit_message>
<xml_diff>
--- a/docs/paper/diagram-sources-2026-09-16/figS5_crossovers.pptx
+++ b/docs/paper/diagram-sources-2026-09-16/figS5_crossovers.pptx
@@ -8,7 +8,7 @@
     <p:sldId id="256" r:id="rId7"/>
     <p:sldId id="257" r:id="rId9"/>
   </p:sldIdLst>
-  <p:sldSz cx="6408000" cy="3186000" type="screen4x3"/>
+  <p:sldSz cx="6408000" cy="2520000" type="screen4x3"/>
   <p:notesSz cx="6858000" cy="9144000"/>
   <p:defaultTextStyle>
     <a:defPPr>
@@ -3588,7 +3588,7 @@
         <p:spPr>
           <a:xfrm>
             <a:off x="0" y="0"/>
-            <a:ext cx="6408000" cy="3186000"/>
+            <a:ext cx="6408000" cy="2520000"/>
           </a:xfrm>
           <a:prstGeom prst="rect">
             <a:avLst/>
@@ -3640,16 +3640,51 @@
         <p:spPr>
           <a:xfrm>
             <a:off x="0" y="0"/>
-            <a:ext cx="2988000" cy="2970000"/>
+            <a:ext cx="1872000" cy="2520000"/>
           </a:xfrm>
           <a:prstGeom prst="rect">
             <a:avLst/>
           </a:prstGeom>
         </p:spPr>
       </p:pic>
+      <p:sp>
+        <p:nvSpPr>
+          <p:cNvPr id="4" name="panel-a"/>
+          <p:cNvSpPr txBox="1"/>
+          <p:nvPr/>
+        </p:nvSpPr>
+        <p:spPr>
+          <a:xfrm>
+            <a:off x="36000" y="126000"/>
+            <a:ext cx="252000" cy="180000"/>
+          </a:xfrm>
+          <a:prstGeom prst="rect">
+            <a:avLst/>
+          </a:prstGeom>
+          <a:noFill/>
+        </p:spPr>
+        <p:txBody>
+          <a:bodyPr wrap="square" lIns="0" rIns="0" tIns="0" bIns="0">
+            <a:spAutoFit/>
+          </a:bodyPr>
+          <a:lstStyle/>
+          <a:p>
+            <a:pPr algn="l"/>
+            <a:r>
+              <a:rPr sz="1000" b="1">
+                <a:solidFill>
+                  <a:srgbClr val="1F2A30"/>
+                </a:solidFill>
+                <a:latin typeface="Arial"/>
+              </a:rPr>
+              <a:t>(a)</a:t>
+            </a:r>
+          </a:p>
+        </p:txBody>
+      </p:sp>
       <p:pic>
         <p:nvPicPr>
-          <p:cNvPr id="4" name="panel-b-image" descr="figS5_crossovers.b.png"/>
+          <p:cNvPr id="5" name="panel-b-image" descr="figS5_crossovers.b.png"/>
           <p:cNvPicPr>
             <a:picLocks noChangeAspect="1"/>
           </p:cNvPicPr>
@@ -3663,8 +3698,8 @@
         </p:blipFill>
         <p:spPr>
           <a:xfrm>
-            <a:off x="3132000" y="0"/>
-            <a:ext cx="3204000" cy="3186000"/>
+            <a:off x="1872000" y="0"/>
+            <a:ext cx="1872000" cy="2520000"/>
           </a:xfrm>
           <a:prstGeom prst="rect">
             <a:avLst/>
@@ -3673,13 +3708,13 @@
       </p:pic>
       <p:sp>
         <p:nvSpPr>
-          <p:cNvPr id="5" name="panel-a"/>
+          <p:cNvPr id="6" name="panel-b"/>
           <p:cNvSpPr txBox="1"/>
           <p:nvPr/>
         </p:nvSpPr>
         <p:spPr>
           <a:xfrm>
-            <a:off x="72000" y="18000"/>
+            <a:off x="1908000" y="126000"/>
             <a:ext cx="252000" cy="180000"/>
           </a:xfrm>
           <a:prstGeom prst="rect">
@@ -3701,20 +3736,44 @@
                 </a:solidFill>
                 <a:latin typeface="Arial"/>
               </a:rPr>
-              <a:t>(a)</a:t>
-            </a:r>
-          </a:p>
-        </p:txBody>
-      </p:sp>
-      <p:sp>
-        <p:nvSpPr>
-          <p:cNvPr id="6" name="panel-b"/>
+              <a:t>(b)</a:t>
+            </a:r>
+          </a:p>
+        </p:txBody>
+      </p:sp>
+      <p:pic>
+        <p:nvPicPr>
+          <p:cNvPr id="7" name="panel-c-image" descr="figS5_crossovers.c.png"/>
+          <p:cNvPicPr>
+            <a:picLocks noChangeAspect="1"/>
+          </p:cNvPicPr>
+          <p:nvPr/>
+        </p:nvPicPr>
+        <p:blipFill>
+          <a:blip r:embed="rId5"/>
+          <a:stretch>
+            <a:fillRect/>
+          </a:stretch>
+        </p:blipFill>
+        <p:spPr>
+          <a:xfrm>
+            <a:off x="3744000" y="0"/>
+            <a:ext cx="2664000" cy="2520000"/>
+          </a:xfrm>
+          <a:prstGeom prst="rect">
+            <a:avLst/>
+          </a:prstGeom>
+        </p:spPr>
+      </p:pic>
+      <p:sp>
+        <p:nvSpPr>
+          <p:cNvPr id="8" name="panel-c"/>
           <p:cNvSpPr txBox="1"/>
           <p:nvPr/>
         </p:nvSpPr>
         <p:spPr>
           <a:xfrm>
-            <a:off x="3204000" y="18000"/>
+            <a:off x="3780000" y="126000"/>
             <a:ext cx="252000" cy="180000"/>
           </a:xfrm>
           <a:prstGeom prst="rect">
@@ -3736,7 +3795,7 @@
                 </a:solidFill>
                 <a:latin typeface="Arial"/>
               </a:rPr>
-              <a:t>(b)</a:t>
+              <a:t>(c)</a:t>
             </a:r>
           </a:p>
         </p:txBody>
@@ -3768,7 +3827,7 @@
         <p:spPr>
           <a:xfrm>
             <a:off x="0" y="0"/>
-            <a:ext cx="6408000" cy="3186000"/>
+            <a:ext cx="6408000" cy="2520000"/>
           </a:xfrm>
           <a:prstGeom prst="rect">
             <a:avLst/>
@@ -3820,16 +3879,51 @@
         <p:spPr>
           <a:xfrm>
             <a:off x="0" y="0"/>
-            <a:ext cx="2988000" cy="2970000"/>
+            <a:ext cx="1872000" cy="2520000"/>
           </a:xfrm>
           <a:prstGeom prst="rect">
             <a:avLst/>
           </a:prstGeom>
         </p:spPr>
       </p:pic>
+      <p:sp>
+        <p:nvSpPr>
+          <p:cNvPr id="4" name="panel-a"/>
+          <p:cNvSpPr txBox="1"/>
+          <p:nvPr/>
+        </p:nvSpPr>
+        <p:spPr>
+          <a:xfrm>
+            <a:off x="36000" y="126000"/>
+            <a:ext cx="252000" cy="180000"/>
+          </a:xfrm>
+          <a:prstGeom prst="rect">
+            <a:avLst/>
+          </a:prstGeom>
+          <a:noFill/>
+        </p:spPr>
+        <p:txBody>
+          <a:bodyPr wrap="square" lIns="0" rIns="0" tIns="0" bIns="0">
+            <a:spAutoFit/>
+          </a:bodyPr>
+          <a:lstStyle/>
+          <a:p>
+            <a:pPr algn="l"/>
+            <a:r>
+              <a:rPr sz="1000" b="1">
+                <a:solidFill>
+                  <a:srgbClr val="1F2A30"/>
+                </a:solidFill>
+                <a:latin typeface="Arial"/>
+              </a:rPr>
+              <a:t>(a)</a:t>
+            </a:r>
+          </a:p>
+        </p:txBody>
+      </p:sp>
       <p:pic>
         <p:nvPicPr>
-          <p:cNvPr id="4" name="panel-b-image" descr="figS5_crossovers.b.ko.png"/>
+          <p:cNvPr id="5" name="panel-b-image" descr="figS5_crossovers.b.ko.png"/>
           <p:cNvPicPr>
             <a:picLocks noChangeAspect="1"/>
           </p:cNvPicPr>
@@ -3843,8 +3937,8 @@
         </p:blipFill>
         <p:spPr>
           <a:xfrm>
-            <a:off x="3132000" y="0"/>
-            <a:ext cx="3204000" cy="3186000"/>
+            <a:off x="1872000" y="0"/>
+            <a:ext cx="1872000" cy="2520000"/>
           </a:xfrm>
           <a:prstGeom prst="rect">
             <a:avLst/>
@@ -3853,13 +3947,13 @@
       </p:pic>
       <p:sp>
         <p:nvSpPr>
-          <p:cNvPr id="5" name="panel-a"/>
+          <p:cNvPr id="6" name="panel-b"/>
           <p:cNvSpPr txBox="1"/>
           <p:nvPr/>
         </p:nvSpPr>
         <p:spPr>
           <a:xfrm>
-            <a:off x="72000" y="18000"/>
+            <a:off x="1908000" y="126000"/>
             <a:ext cx="252000" cy="180000"/>
           </a:xfrm>
           <a:prstGeom prst="rect">
@@ -3881,20 +3975,44 @@
                 </a:solidFill>
                 <a:latin typeface="Arial"/>
               </a:rPr>
-              <a:t>(a)</a:t>
-            </a:r>
-          </a:p>
-        </p:txBody>
-      </p:sp>
-      <p:sp>
-        <p:nvSpPr>
-          <p:cNvPr id="6" name="panel-b"/>
+              <a:t>(b)</a:t>
+            </a:r>
+          </a:p>
+        </p:txBody>
+      </p:sp>
+      <p:pic>
+        <p:nvPicPr>
+          <p:cNvPr id="7" name="panel-c-image" descr="figS5_crossovers.c.ko.png"/>
+          <p:cNvPicPr>
+            <a:picLocks noChangeAspect="1"/>
+          </p:cNvPicPr>
+          <p:nvPr/>
+        </p:nvPicPr>
+        <p:blipFill>
+          <a:blip r:embed="rId5"/>
+          <a:stretch>
+            <a:fillRect/>
+          </a:stretch>
+        </p:blipFill>
+        <p:spPr>
+          <a:xfrm>
+            <a:off x="3744000" y="0"/>
+            <a:ext cx="2664000" cy="2520000"/>
+          </a:xfrm>
+          <a:prstGeom prst="rect">
+            <a:avLst/>
+          </a:prstGeom>
+        </p:spPr>
+      </p:pic>
+      <p:sp>
+        <p:nvSpPr>
+          <p:cNvPr id="8" name="panel-c"/>
           <p:cNvSpPr txBox="1"/>
           <p:nvPr/>
         </p:nvSpPr>
         <p:spPr>
           <a:xfrm>
-            <a:off x="3204000" y="18000"/>
+            <a:off x="3780000" y="126000"/>
             <a:ext cx="252000" cy="180000"/>
           </a:xfrm>
           <a:prstGeom prst="rect">
@@ -3916,7 +4034,7 @@
                 </a:solidFill>
                 <a:latin typeface="Arial"/>
               </a:rPr>
-              <a:t>(b)</a:t>
+              <a:t>(c)</a:t>
             </a:r>
           </a:p>
         </p:txBody>

</xml_diff>